<commit_message>
Revert "docs: publish latest docs"
This reverts commit 5e7b07ce180c23a12a34e7dcb1ebe73a5301c601.
</commit_message>
<xml_diff>
--- a/latest/macos-app-install/macos-app-install-slides.pptx
+++ b/latest/macos-app-install/macos-app-install-slides.pptx
@@ -5,13 +5,13 @@
     <p:sldMasterId xmlns:r="http://schemas.openxmlformats.org/officeDocument/2006/relationships" id="2147483648" r:id="rId1"/>
   </p:sldMasterIdLst>
   <p:sldIdLst>
-    <p:sldId id="256" r:id="R362d945d8c304965"/>
-    <p:sldId id="257" r:id="Raf0925b5b4114bc8"/>
-    <p:sldId id="258" r:id="Rf941da98383a426a"/>
-    <p:sldId id="259" r:id="Racf2455c10ee41cc"/>
-    <p:sldId id="260" r:id="R3b4311ec7e7c4ece"/>
-    <p:sldId id="261" r:id="Rd01600e006f84c26"/>
-    <p:sldId id="262" r:id="R108fc02600c64604"/>
+    <p:sldId id="256" r:id="R96ffd194586d4fb9"/>
+    <p:sldId id="257" r:id="Rbab24dc0122c4a2c"/>
+    <p:sldId id="258" r:id="R8abc5d51aeb74c33"/>
+    <p:sldId id="259" r:id="Rf1be90228ba045bb"/>
+    <p:sldId id="260" r:id="Rb1bdc34b25f8499b"/>
+    <p:sldId id="261" r:id="R1a58305e061c4838"/>
+    <p:sldId id="262" r:id="R674cb35febd14c21"/>
   </p:sldIdLst>
   <p:sldSz cx="12192000" cy="6858000" type="screen16x9"/>
   <p:notesSz cx="6858000" cy="9144000"/>
@@ -327,7 +327,7 @@
           <p:nvPr/>
         </p:nvPicPr>
         <p:blipFill>
-          <a:blip xmlns:r="http://schemas.openxmlformats.org/officeDocument/2006/relationships" xmlns:a="http://schemas.openxmlformats.org/drawingml/2006/main" r:embed="R49d3fb7a960747aa"/>
+          <a:blip xmlns:r="http://schemas.openxmlformats.org/officeDocument/2006/relationships" xmlns:a="http://schemas.openxmlformats.org/drawingml/2006/main" r:embed="R67a89efc3a944aee"/>
           <a:stretch xmlns:a="http://schemas.openxmlformats.org/drawingml/2006/main">
             <a:fillRect/>
           </a:stretch>
@@ -366,7 +366,7 @@
           <p:nvPr/>
         </p:nvPicPr>
         <p:blipFill>
-          <a:blip xmlns:r="http://schemas.openxmlformats.org/officeDocument/2006/relationships" xmlns:a="http://schemas.openxmlformats.org/drawingml/2006/main" r:embed="R55bf11e429bc4c40"/>
+          <a:blip xmlns:r="http://schemas.openxmlformats.org/officeDocument/2006/relationships" xmlns:a="http://schemas.openxmlformats.org/drawingml/2006/main" r:embed="R5aba7b04ffbf4eda"/>
           <a:stretch xmlns:a="http://schemas.openxmlformats.org/drawingml/2006/main">
             <a:fillRect/>
           </a:stretch>
@@ -405,7 +405,7 @@
           <p:nvPr/>
         </p:nvPicPr>
         <p:blipFill>
-          <a:blip xmlns:r="http://schemas.openxmlformats.org/officeDocument/2006/relationships" xmlns:a="http://schemas.openxmlformats.org/drawingml/2006/main" r:embed="R1b1e2335eab344f3"/>
+          <a:blip xmlns:r="http://schemas.openxmlformats.org/officeDocument/2006/relationships" xmlns:a="http://schemas.openxmlformats.org/drawingml/2006/main" r:embed="R70675975c73b4935"/>
           <a:stretch xmlns:a="http://schemas.openxmlformats.org/drawingml/2006/main">
             <a:fillRect/>
           </a:stretch>
@@ -444,7 +444,7 @@
           <p:nvPr/>
         </p:nvPicPr>
         <p:blipFill>
-          <a:blip xmlns:r="http://schemas.openxmlformats.org/officeDocument/2006/relationships" xmlns:a="http://schemas.openxmlformats.org/drawingml/2006/main" r:embed="R9fa6478e4df54bca"/>
+          <a:blip xmlns:r="http://schemas.openxmlformats.org/officeDocument/2006/relationships" xmlns:a="http://schemas.openxmlformats.org/drawingml/2006/main" r:embed="R5c927a6e2089426f"/>
           <a:stretch xmlns:a="http://schemas.openxmlformats.org/drawingml/2006/main">
             <a:fillRect/>
           </a:stretch>
@@ -483,7 +483,7 @@
           <p:nvPr/>
         </p:nvPicPr>
         <p:blipFill>
-          <a:blip xmlns:r="http://schemas.openxmlformats.org/officeDocument/2006/relationships" xmlns:a="http://schemas.openxmlformats.org/drawingml/2006/main" r:embed="R40370a09ce524fd9"/>
+          <a:blip xmlns:r="http://schemas.openxmlformats.org/officeDocument/2006/relationships" xmlns:a="http://schemas.openxmlformats.org/drawingml/2006/main" r:embed="Rda9adeb847ca4480"/>
           <a:stretch xmlns:a="http://schemas.openxmlformats.org/drawingml/2006/main">
             <a:fillRect/>
           </a:stretch>
@@ -522,7 +522,7 @@
           <p:nvPr/>
         </p:nvPicPr>
         <p:blipFill>
-          <a:blip xmlns:r="http://schemas.openxmlformats.org/officeDocument/2006/relationships" xmlns:a="http://schemas.openxmlformats.org/drawingml/2006/main" r:embed="R436f171a133d49ec"/>
+          <a:blip xmlns:r="http://schemas.openxmlformats.org/officeDocument/2006/relationships" xmlns:a="http://schemas.openxmlformats.org/drawingml/2006/main" r:embed="R1ffee1ff17714fef"/>
           <a:stretch xmlns:a="http://schemas.openxmlformats.org/drawingml/2006/main">
             <a:fillRect/>
           </a:stretch>
@@ -561,7 +561,7 @@
           <p:nvPr/>
         </p:nvPicPr>
         <p:blipFill>
-          <a:blip xmlns:r="http://schemas.openxmlformats.org/officeDocument/2006/relationships" xmlns:a="http://schemas.openxmlformats.org/drawingml/2006/main" r:embed="R418f44c9c47f488f"/>
+          <a:blip xmlns:r="http://schemas.openxmlformats.org/officeDocument/2006/relationships" xmlns:a="http://schemas.openxmlformats.org/drawingml/2006/main" r:embed="Rbb8f2dec7fec497f"/>
           <a:stretch xmlns:a="http://schemas.openxmlformats.org/drawingml/2006/main">
             <a:fillRect/>
           </a:stretch>

</xml_diff>